<commit_message>
Frontend Setup- Master user dashboard
</commit_message>
<xml_diff>
--- a/.lessons/51 Frontend Template Setup And Mastering/5 Frontend Setup- Master user dashboard/1.pptx
+++ b/.lessons/51 Frontend Template Setup And Mastering/5 Frontend Setup- Master user dashboard/1.pptx
@@ -7,7 +7,12 @@
   <p:sldIdLst>
     <p:sldId id="413" r:id="rId2"/>
     <p:sldId id="414" r:id="rId3"/>
-    <p:sldId id="400" r:id="rId4"/>
+    <p:sldId id="415" r:id="rId4"/>
+    <p:sldId id="416" r:id="rId5"/>
+    <p:sldId id="417" r:id="rId6"/>
+    <p:sldId id="418" r:id="rId7"/>
+    <p:sldId id="419" r:id="rId8"/>
+    <p:sldId id="400" r:id="rId9"/>
   </p:sldIdLst>
   <p:sldSz cx="12192000" cy="6858000"/>
   <p:notesSz cx="6858000" cy="9144000"/>
@@ -261,7 +266,7 @@
           <a:p>
             <a:fld id="{3E102D2E-813C-461C-9963-687A650C48C0}" type="datetimeFigureOut">
               <a:rPr lang="en-US" smtClean="0"/>
-              <a:t>6/26/2025</a:t>
+              <a:t>7/31/2025</a:t>
             </a:fld>
             <a:endParaRPr lang="en-US"/>
           </a:p>
@@ -459,7 +464,7 @@
           <a:p>
             <a:fld id="{3E102D2E-813C-461C-9963-687A650C48C0}" type="datetimeFigureOut">
               <a:rPr lang="en-US" smtClean="0"/>
-              <a:t>6/26/2025</a:t>
+              <a:t>7/31/2025</a:t>
             </a:fld>
             <a:endParaRPr lang="en-US"/>
           </a:p>
@@ -667,7 +672,7 @@
           <a:p>
             <a:fld id="{3E102D2E-813C-461C-9963-687A650C48C0}" type="datetimeFigureOut">
               <a:rPr lang="en-US" smtClean="0"/>
-              <a:t>6/26/2025</a:t>
+              <a:t>7/31/2025</a:t>
             </a:fld>
             <a:endParaRPr lang="en-US"/>
           </a:p>
@@ -865,7 +870,7 @@
           <a:p>
             <a:fld id="{3E102D2E-813C-461C-9963-687A650C48C0}" type="datetimeFigureOut">
               <a:rPr lang="en-US" smtClean="0"/>
-              <a:t>6/26/2025</a:t>
+              <a:t>7/31/2025</a:t>
             </a:fld>
             <a:endParaRPr lang="en-US"/>
           </a:p>
@@ -1140,7 +1145,7 @@
           <a:p>
             <a:fld id="{3E102D2E-813C-461C-9963-687A650C48C0}" type="datetimeFigureOut">
               <a:rPr lang="en-US" smtClean="0"/>
-              <a:t>6/26/2025</a:t>
+              <a:t>7/31/2025</a:t>
             </a:fld>
             <a:endParaRPr lang="en-US"/>
           </a:p>
@@ -1405,7 +1410,7 @@
           <a:p>
             <a:fld id="{3E102D2E-813C-461C-9963-687A650C48C0}" type="datetimeFigureOut">
               <a:rPr lang="en-US" smtClean="0"/>
-              <a:t>6/26/2025</a:t>
+              <a:t>7/31/2025</a:t>
             </a:fld>
             <a:endParaRPr lang="en-US"/>
           </a:p>
@@ -1817,7 +1822,7 @@
           <a:p>
             <a:fld id="{3E102D2E-813C-461C-9963-687A650C48C0}" type="datetimeFigureOut">
               <a:rPr lang="en-US" smtClean="0"/>
-              <a:t>6/26/2025</a:t>
+              <a:t>7/31/2025</a:t>
             </a:fld>
             <a:endParaRPr lang="en-US"/>
           </a:p>
@@ -1958,7 +1963,7 @@
           <a:p>
             <a:fld id="{3E102D2E-813C-461C-9963-687A650C48C0}" type="datetimeFigureOut">
               <a:rPr lang="en-US" smtClean="0"/>
-              <a:t>6/26/2025</a:t>
+              <a:t>7/31/2025</a:t>
             </a:fld>
             <a:endParaRPr lang="en-US"/>
           </a:p>
@@ -2071,7 +2076,7 @@
           <a:p>
             <a:fld id="{3E102D2E-813C-461C-9963-687A650C48C0}" type="datetimeFigureOut">
               <a:rPr lang="en-US" smtClean="0"/>
-              <a:t>6/26/2025</a:t>
+              <a:t>7/31/2025</a:t>
             </a:fld>
             <a:endParaRPr lang="en-US"/>
           </a:p>
@@ -2382,7 +2387,7 @@
           <a:p>
             <a:fld id="{3E102D2E-813C-461C-9963-687A650C48C0}" type="datetimeFigureOut">
               <a:rPr lang="en-US" smtClean="0"/>
-              <a:t>6/26/2025</a:t>
+              <a:t>7/31/2025</a:t>
             </a:fld>
             <a:endParaRPr lang="en-US"/>
           </a:p>
@@ -2670,7 +2675,7 @@
           <a:p>
             <a:fld id="{3E102D2E-813C-461C-9963-687A650C48C0}" type="datetimeFigureOut">
               <a:rPr lang="en-US" smtClean="0"/>
-              <a:t>6/26/2025</a:t>
+              <a:t>7/31/2025</a:t>
             </a:fld>
             <a:endParaRPr lang="en-US"/>
           </a:p>
@@ -2911,7 +2916,7 @@
           <a:p>
             <a:fld id="{3E102D2E-813C-461C-9963-687A650C48C0}" type="datetimeFigureOut">
               <a:rPr lang="en-US" smtClean="0"/>
-              <a:t>6/26/2025</a:t>
+              <a:t>7/31/2025</a:t>
             </a:fld>
             <a:endParaRPr lang="en-US"/>
           </a:p>
@@ -3349,7 +3354,7 @@
         <p:spPr>
           <a:xfrm>
             <a:off x="217714" y="255046"/>
-            <a:ext cx="11756571" cy="355354"/>
+            <a:ext cx="11756571" cy="955518"/>
           </a:xfrm>
           <a:prstGeom prst="rect">
             <a:avLst/>
@@ -3369,18 +3374,223 @@
               <a:buNone/>
             </a:pPr>
             <a:r>
-              <a:rPr kumimoji="0" lang="en-US" altLang="en-US" sz="1300" b="0" i="0" u="none" strike="noStrike" cap="none" normalizeH="0" baseline="0">
-                <a:ln>
-                  <a:noFill/>
-                </a:ln>
-                <a:solidFill>
-                  <a:schemeClr val="tx1"/>
-                </a:solidFill>
-                <a:effectLst/>
-                <a:latin typeface="Arial" panose="020B0604020202020204" pitchFamily="34" charset="0"/>
-              </a:rPr>
-              <a:t>.</a:t>
-            </a:r>
+              <a:rPr lang="az-Latn-AZ" altLang="en-US" sz="1300">
+                <a:latin typeface="Arial" panose="020B0604020202020204" pitchFamily="34" charset="0"/>
+              </a:rPr>
+              <a:t>Bu dərs </a:t>
+            </a:r>
+            <a:r>
+              <a:rPr lang="az-Latn-AZ" altLang="en-US" sz="1300" b="1">
+                <a:latin typeface="Arial" panose="020B0604020202020204" pitchFamily="34" charset="0"/>
+              </a:rPr>
+              <a:t>USER</a:t>
+            </a:r>
+            <a:r>
+              <a:rPr lang="az-Latn-AZ" altLang="en-US" sz="1300">
+                <a:latin typeface="Arial" panose="020B0604020202020204" pitchFamily="34" charset="0"/>
+              </a:rPr>
+              <a:t> </a:t>
+            </a:r>
+            <a:r>
+              <a:rPr lang="az-Latn-AZ" altLang="en-US" sz="1300" b="1">
+                <a:latin typeface="Arial" panose="020B0604020202020204" pitchFamily="34" charset="0"/>
+              </a:rPr>
+              <a:t>panelini</a:t>
+            </a:r>
+            <a:r>
+              <a:rPr lang="az-Latn-AZ" altLang="en-US" sz="1300">
+                <a:latin typeface="Arial" panose="020B0604020202020204" pitchFamily="34" charset="0"/>
+              </a:rPr>
+              <a:t> konfiqurasiya edəcəyik.</a:t>
+            </a:r>
+          </a:p>
+          <a:p>
+            <a:pPr>
+              <a:lnSpc>
+                <a:spcPct val="150000"/>
+              </a:lnSpc>
+              <a:buNone/>
+            </a:pPr>
+            <a:endParaRPr kumimoji="0" lang="az-Latn-AZ" altLang="en-US" sz="1300" b="0" i="0" u="none" strike="noStrike" cap="none" normalizeH="0" baseline="0">
+              <a:ln>
+                <a:noFill/>
+              </a:ln>
+              <a:solidFill>
+                <a:schemeClr val="tx1"/>
+              </a:solidFill>
+              <a:effectLst/>
+              <a:latin typeface="Arial" panose="020B0604020202020204" pitchFamily="34" charset="0"/>
+            </a:endParaRPr>
+          </a:p>
+          <a:p>
+            <a:pPr>
+              <a:lnSpc>
+                <a:spcPct val="150000"/>
+              </a:lnSpc>
+              <a:buNone/>
+            </a:pPr>
+            <a:r>
+              <a:rPr lang="az-Latn-AZ" altLang="en-US" sz="1300">
+                <a:latin typeface="Arial" panose="020B0604020202020204" pitchFamily="34" charset="0"/>
+              </a:rPr>
+              <a:t>İlk öncə </a:t>
+            </a:r>
+            <a:r>
+              <a:rPr lang="az-Latn-AZ" altLang="en-US" sz="1300" b="1">
+                <a:latin typeface="Arial" panose="020B0604020202020204" pitchFamily="34" charset="0"/>
+              </a:rPr>
+              <a:t>user</a:t>
+            </a:r>
+            <a:r>
+              <a:rPr lang="az-Latn-AZ" altLang="en-US" sz="1300">
+                <a:latin typeface="Arial" panose="020B0604020202020204" pitchFamily="34" charset="0"/>
+              </a:rPr>
+              <a:t> kimi sistemə daxil oluruq.</a:t>
+            </a:r>
+            <a:endParaRPr kumimoji="0" lang="en-US" altLang="en-US" sz="1300" b="0" i="0" u="none" strike="noStrike" cap="none" normalizeH="0" baseline="0">
+              <a:ln>
+                <a:noFill/>
+              </a:ln>
+              <a:solidFill>
+                <a:schemeClr val="tx1"/>
+              </a:solidFill>
+              <a:effectLst/>
+              <a:latin typeface="Arial" panose="020B0604020202020204" pitchFamily="34" charset="0"/>
+            </a:endParaRPr>
+          </a:p>
+        </p:txBody>
+      </p:sp>
+      <p:pic>
+        <p:nvPicPr>
+          <p:cNvPr id="4" name="Picture 3">
+            <a:extLst>
+              <a:ext uri="{FF2B5EF4-FFF2-40B4-BE49-F238E27FC236}">
+                <a16:creationId xmlns:a16="http://schemas.microsoft.com/office/drawing/2014/main" id="{FDC372C7-08CB-13F5-85A7-1F02282DEDC8}"/>
+              </a:ext>
+            </a:extLst>
+          </p:cNvPr>
+          <p:cNvPicPr>
+            <a:picLocks noChangeAspect="1"/>
+          </p:cNvPicPr>
+          <p:nvPr/>
+        </p:nvPicPr>
+        <p:blipFill>
+          <a:blip r:embed="rId2"/>
+          <a:stretch>
+            <a:fillRect/>
+          </a:stretch>
+        </p:blipFill>
+        <p:spPr>
+          <a:xfrm>
+            <a:off x="4492388" y="1692883"/>
+            <a:ext cx="3207221" cy="2267626"/>
+          </a:xfrm>
+          <a:prstGeom prst="rect">
+            <a:avLst/>
+          </a:prstGeom>
+          <a:ln w="38100" cap="sq">
+            <a:solidFill>
+              <a:srgbClr val="000000"/>
+            </a:solidFill>
+            <a:prstDash val="solid"/>
+            <a:miter lim="800000"/>
+          </a:ln>
+          <a:effectLst>
+            <a:outerShdw blurRad="50800" dist="38100" dir="2700000" algn="tl" rotWithShape="0">
+              <a:srgbClr val="000000">
+                <a:alpha val="43000"/>
+              </a:srgbClr>
+            </a:outerShdw>
+          </a:effectLst>
+        </p:spPr>
+      </p:pic>
+      <p:pic>
+        <p:nvPicPr>
+          <p:cNvPr id="6" name="Picture 5">
+            <a:extLst>
+              <a:ext uri="{FF2B5EF4-FFF2-40B4-BE49-F238E27FC236}">
+                <a16:creationId xmlns:a16="http://schemas.microsoft.com/office/drawing/2014/main" id="{9CE45633-3AFC-906B-FBE3-EDD87385EE3A}"/>
+              </a:ext>
+            </a:extLst>
+          </p:cNvPr>
+          <p:cNvPicPr>
+            <a:picLocks noChangeAspect="1"/>
+          </p:cNvPicPr>
+          <p:nvPr/>
+        </p:nvPicPr>
+        <p:blipFill>
+          <a:blip r:embed="rId3"/>
+          <a:stretch>
+            <a:fillRect/>
+          </a:stretch>
+        </p:blipFill>
+        <p:spPr>
+          <a:xfrm>
+            <a:off x="0" y="4697875"/>
+            <a:ext cx="12192000" cy="2160125"/>
+          </a:xfrm>
+          <a:prstGeom prst="rect">
+            <a:avLst/>
+          </a:prstGeom>
+          <a:ln w="38100" cap="sq">
+            <a:solidFill>
+              <a:srgbClr val="000000"/>
+            </a:solidFill>
+            <a:prstDash val="solid"/>
+            <a:miter lim="800000"/>
+          </a:ln>
+          <a:effectLst>
+            <a:outerShdw blurRad="50800" dist="38100" dir="2700000" algn="tl" rotWithShape="0">
+              <a:srgbClr val="000000">
+                <a:alpha val="43000"/>
+              </a:srgbClr>
+            </a:outerShdw>
+          </a:effectLst>
+        </p:spPr>
+      </p:pic>
+      <p:sp>
+        <p:nvSpPr>
+          <p:cNvPr id="7" name="Arrow: Down 6">
+            <a:extLst>
+              <a:ext uri="{FF2B5EF4-FFF2-40B4-BE49-F238E27FC236}">
+                <a16:creationId xmlns:a16="http://schemas.microsoft.com/office/drawing/2014/main" id="{DFC61E17-5AA5-8EA1-2C92-5CA5C6323439}"/>
+              </a:ext>
+            </a:extLst>
+          </p:cNvPr>
+          <p:cNvSpPr/>
+          <p:nvPr/>
+        </p:nvSpPr>
+        <p:spPr>
+          <a:xfrm>
+            <a:off x="5890724" y="4161452"/>
+            <a:ext cx="410547" cy="354564"/>
+          </a:xfrm>
+          <a:prstGeom prst="downArrow">
+            <a:avLst/>
+          </a:prstGeom>
+        </p:spPr>
+        <p:style>
+          <a:lnRef idx="2">
+            <a:schemeClr val="dk1">
+              <a:shade val="15000"/>
+            </a:schemeClr>
+          </a:lnRef>
+          <a:fillRef idx="1">
+            <a:schemeClr val="dk1"/>
+          </a:fillRef>
+          <a:effectRef idx="0">
+            <a:schemeClr val="dk1"/>
+          </a:effectRef>
+          <a:fontRef idx="minor">
+            <a:schemeClr val="lt1"/>
+          </a:fontRef>
+        </p:style>
+        <p:txBody>
+          <a:bodyPr rtlCol="0" anchor="ctr"/>
+          <a:lstStyle/>
+          <a:p>
+            <a:pPr algn="ctr"/>
+            <a:endParaRPr lang="en-US"/>
           </a:p>
         </p:txBody>
       </p:sp>
@@ -3434,8 +3644,8 @@
         </p:nvSpPr>
         <p:spPr>
           <a:xfrm>
-            <a:off x="217714" y="255046"/>
-            <a:ext cx="11756571" cy="355354"/>
+            <a:off x="217714" y="208393"/>
+            <a:ext cx="11756571" cy="955518"/>
           </a:xfrm>
           <a:prstGeom prst="rect">
             <a:avLst/>
@@ -3455,21 +3665,158 @@
               <a:buNone/>
             </a:pPr>
             <a:r>
-              <a:rPr kumimoji="0" lang="en-US" altLang="en-US" sz="1300" b="0" i="0" u="none" strike="noStrike" cap="none" normalizeH="0" baseline="0">
-                <a:ln>
-                  <a:noFill/>
-                </a:ln>
-                <a:solidFill>
-                  <a:schemeClr val="tx1"/>
-                </a:solidFill>
-                <a:effectLst/>
-                <a:latin typeface="Arial" panose="020B0604020202020204" pitchFamily="34" charset="0"/>
-              </a:rPr>
-              <a:t>.</a:t>
-            </a:r>
-          </a:p>
-        </p:txBody>
-      </p:sp>
+              <a:rPr lang="az-Latn-AZ" altLang="en-US" sz="1300">
+                <a:latin typeface="Arial" panose="020B0604020202020204" pitchFamily="34" charset="0"/>
+              </a:rPr>
+              <a:t>1) `</a:t>
+            </a:r>
+            <a:r>
+              <a:rPr lang="az-Latn-AZ" altLang="en-US" sz="1300" b="1">
+                <a:latin typeface="Arial" panose="020B0604020202020204" pitchFamily="34" charset="0"/>
+              </a:rPr>
+              <a:t>dashboard.html</a:t>
+            </a:r>
+            <a:r>
+              <a:rPr lang="az-Latn-AZ" altLang="en-US" sz="1300">
+                <a:latin typeface="Arial" panose="020B0604020202020204" pitchFamily="34" charset="0"/>
+              </a:rPr>
+              <a:t>` elementlərini, </a:t>
+            </a:r>
+            <a:r>
+              <a:rPr lang="en-US" altLang="en-US" sz="1300">
+                <a:latin typeface="Arial" panose="020B0604020202020204" pitchFamily="34" charset="0"/>
+              </a:rPr>
+              <a:t>`</a:t>
+            </a:r>
+            <a:r>
+              <a:rPr lang="en-US" altLang="en-US" sz="1300" b="1">
+                <a:latin typeface="Arial" panose="020B0604020202020204" pitchFamily="34" charset="0"/>
+              </a:rPr>
+              <a:t>resources\views\frontend\dashboard\layouts\master.blade.php</a:t>
+            </a:r>
+            <a:r>
+              <a:rPr lang="en-US" altLang="en-US" sz="1300">
+                <a:latin typeface="Arial" panose="020B0604020202020204" pitchFamily="34" charset="0"/>
+              </a:rPr>
+              <a:t>` </a:t>
+            </a:r>
+            <a:r>
+              <a:rPr lang="az-Latn-AZ" altLang="en-US" sz="1300">
+                <a:latin typeface="Arial" panose="020B0604020202020204" pitchFamily="34" charset="0"/>
+              </a:rPr>
+              <a:t>adında fayl yaradaraq, onun içinə köçürürük.</a:t>
+            </a:r>
+          </a:p>
+          <a:p>
+            <a:pPr>
+              <a:lnSpc>
+                <a:spcPct val="150000"/>
+              </a:lnSpc>
+              <a:buNone/>
+            </a:pPr>
+            <a:endParaRPr kumimoji="0" lang="az-Latn-AZ" altLang="en-US" sz="1300" b="0" i="0" u="none" strike="noStrike" cap="none" normalizeH="0" baseline="0">
+              <a:ln>
+                <a:noFill/>
+              </a:ln>
+              <a:solidFill>
+                <a:schemeClr val="tx1"/>
+              </a:solidFill>
+              <a:effectLst/>
+              <a:latin typeface="Arial" panose="020B0604020202020204" pitchFamily="34" charset="0"/>
+            </a:endParaRPr>
+          </a:p>
+          <a:p>
+            <a:pPr>
+              <a:lnSpc>
+                <a:spcPct val="150000"/>
+              </a:lnSpc>
+              <a:buNone/>
+            </a:pPr>
+            <a:r>
+              <a:rPr lang="az-Latn-AZ" altLang="en-US" sz="1300">
+                <a:latin typeface="Arial" panose="020B0604020202020204" pitchFamily="34" charset="0"/>
+              </a:rPr>
+              <a:t>2) </a:t>
+            </a:r>
+            <a:r>
+              <a:rPr lang="az-Latn-AZ" altLang="en-US" sz="1300" b="1">
+                <a:latin typeface="Arial" panose="020B0604020202020204" pitchFamily="34" charset="0"/>
+              </a:rPr>
+              <a:t>link</a:t>
+            </a:r>
+            <a:r>
+              <a:rPr lang="az-Latn-AZ" altLang="en-US" sz="1300">
+                <a:latin typeface="Arial" panose="020B0604020202020204" pitchFamily="34" charset="0"/>
+              </a:rPr>
+              <a:t> və </a:t>
+            </a:r>
+            <a:r>
+              <a:rPr lang="az-Latn-AZ" altLang="en-US" sz="1300" b="1">
+                <a:latin typeface="Arial" panose="020B0604020202020204" pitchFamily="34" charset="0"/>
+              </a:rPr>
+              <a:t>script</a:t>
+            </a:r>
+            <a:r>
+              <a:rPr lang="az-Latn-AZ" altLang="en-US" sz="1300">
+                <a:latin typeface="Arial" panose="020B0604020202020204" pitchFamily="34" charset="0"/>
+              </a:rPr>
+              <a:t> elementlərindəki yolları, </a:t>
+            </a:r>
+            <a:r>
+              <a:rPr lang="az-Latn-AZ" altLang="en-US" sz="1300" b="1">
+                <a:latin typeface="Arial" panose="020B0604020202020204" pitchFamily="34" charset="0"/>
+              </a:rPr>
+              <a:t>asset() </a:t>
+            </a:r>
+            <a:r>
+              <a:rPr lang="az-Latn-AZ" altLang="en-US" sz="1300">
+                <a:latin typeface="Arial" panose="020B0604020202020204" pitchFamily="34" charset="0"/>
+              </a:rPr>
+              <a:t>metodu ilə təkrar çağırırıq.</a:t>
+            </a:r>
+            <a:endParaRPr kumimoji="0" lang="en-US" altLang="en-US" sz="1300" b="0" i="0" u="none" strike="noStrike" cap="none" normalizeH="0" baseline="0">
+              <a:ln>
+                <a:noFill/>
+              </a:ln>
+              <a:solidFill>
+                <a:schemeClr val="tx1"/>
+              </a:solidFill>
+              <a:effectLst/>
+              <a:latin typeface="Arial" panose="020B0604020202020204" pitchFamily="34" charset="0"/>
+            </a:endParaRPr>
+          </a:p>
+        </p:txBody>
+      </p:sp>
+      <p:pic>
+        <p:nvPicPr>
+          <p:cNvPr id="6" name="Picture 5">
+            <a:extLst>
+              <a:ext uri="{FF2B5EF4-FFF2-40B4-BE49-F238E27FC236}">
+                <a16:creationId xmlns:a16="http://schemas.microsoft.com/office/drawing/2014/main" id="{07D9F5AF-E1FF-CA36-88D0-C558BC9F7D48}"/>
+              </a:ext>
+            </a:extLst>
+          </p:cNvPr>
+          <p:cNvPicPr>
+            <a:picLocks noChangeAspect="1"/>
+          </p:cNvPicPr>
+          <p:nvPr/>
+        </p:nvPicPr>
+        <p:blipFill>
+          <a:blip r:embed="rId2"/>
+          <a:stretch>
+            <a:fillRect/>
+          </a:stretch>
+        </p:blipFill>
+        <p:spPr>
+          <a:xfrm>
+            <a:off x="5001208" y="1611990"/>
+            <a:ext cx="7190792" cy="5246010"/>
+          </a:xfrm>
+          <a:prstGeom prst="rect">
+            <a:avLst/>
+          </a:prstGeom>
+        </p:spPr>
+      </p:pic>
     </p:spTree>
     <p:extLst>
       <p:ext uri="{BB962C8B-B14F-4D97-AF65-F5344CB8AC3E}">
@@ -3484,6 +3831,888 @@
 </file>
 
 <file path=ppt/slides/slide3.xml><?xml version="1.0" encoding="utf-8"?>
+<p:sld xmlns:a="http://schemas.openxmlformats.org/drawingml/2006/main" xmlns:r="http://schemas.openxmlformats.org/officeDocument/2006/relationships" xmlns:p="http://schemas.openxmlformats.org/presentationml/2006/main">
+  <p:cSld>
+    <p:spTree>
+      <p:nvGrpSpPr>
+        <p:cNvPr id="1" name="">
+          <a:extLst>
+            <a:ext uri="{FF2B5EF4-FFF2-40B4-BE49-F238E27FC236}">
+              <a16:creationId xmlns:a16="http://schemas.microsoft.com/office/drawing/2014/main" id="{113F6DA2-F857-3B6C-EF7E-E09AD429FBB3}"/>
+            </a:ext>
+          </a:extLst>
+        </p:cNvPr>
+        <p:cNvGrpSpPr/>
+        <p:nvPr/>
+      </p:nvGrpSpPr>
+      <p:grpSpPr>
+        <a:xfrm>
+          <a:off x="0" y="0"/>
+          <a:ext cx="0" cy="0"/>
+          <a:chOff x="0" y="0"/>
+          <a:chExt cx="0" cy="0"/>
+        </a:xfrm>
+      </p:grpSpPr>
+      <p:sp>
+        <p:nvSpPr>
+          <p:cNvPr id="3" name="TextBox 2">
+            <a:extLst>
+              <a:ext uri="{FF2B5EF4-FFF2-40B4-BE49-F238E27FC236}">
+                <a16:creationId xmlns:a16="http://schemas.microsoft.com/office/drawing/2014/main" id="{4ED2C419-9C75-A72D-26E4-2BE00277D7DD}"/>
+              </a:ext>
+            </a:extLst>
+          </p:cNvPr>
+          <p:cNvSpPr txBox="1"/>
+          <p:nvPr/>
+        </p:nvSpPr>
+        <p:spPr>
+          <a:xfrm>
+            <a:off x="217714" y="199063"/>
+            <a:ext cx="11756571" cy="2155847"/>
+          </a:xfrm>
+          <a:prstGeom prst="rect">
+            <a:avLst/>
+          </a:prstGeom>
+          <a:noFill/>
+        </p:spPr>
+        <p:txBody>
+          <a:bodyPr wrap="square">
+            <a:spAutoFit/>
+          </a:bodyPr>
+          <a:lstStyle/>
+          <a:p>
+            <a:pPr>
+              <a:lnSpc>
+                <a:spcPct val="150000"/>
+              </a:lnSpc>
+              <a:buNone/>
+            </a:pPr>
+            <a:r>
+              <a:rPr lang="en-US" altLang="en-US" sz="1300">
+                <a:latin typeface="Arial" panose="020B0604020202020204" pitchFamily="34" charset="0"/>
+              </a:rPr>
+              <a:t>`</a:t>
+            </a:r>
+            <a:r>
+              <a:rPr lang="en-US" altLang="en-US" sz="1300" b="1">
+                <a:latin typeface="Arial" panose="020B0604020202020204" pitchFamily="34" charset="0"/>
+              </a:rPr>
+              <a:t> resources\views\frontend\dashboard\layouts\master.blade.php </a:t>
+            </a:r>
+            <a:r>
+              <a:rPr lang="en-US" altLang="en-US" sz="1300">
+                <a:latin typeface="Arial" panose="020B0604020202020204" pitchFamily="34" charset="0"/>
+              </a:rPr>
+              <a:t>` fayl</a:t>
+            </a:r>
+            <a:r>
+              <a:rPr lang="az-Latn-AZ" altLang="en-US" sz="1300">
+                <a:latin typeface="Arial" panose="020B0604020202020204" pitchFamily="34" charset="0"/>
+              </a:rPr>
+              <a:t>ına əlavə etdiyimiz elementlərin nəticəsini görə bilmək üçün, müvəqqətidə olsa `</a:t>
+            </a:r>
+            <a:r>
+              <a:rPr lang="az-Latn-AZ" altLang="en-US" sz="1300" b="1">
+                <a:latin typeface="Arial" panose="020B0604020202020204" pitchFamily="34" charset="0"/>
+              </a:rPr>
+              <a:t>routes\web.php</a:t>
+            </a:r>
+            <a:r>
+              <a:rPr lang="az-Latn-AZ" altLang="en-US" sz="1300">
+                <a:latin typeface="Arial" panose="020B0604020202020204" pitchFamily="34" charset="0"/>
+              </a:rPr>
+              <a:t>` faylındakı işarələnən </a:t>
+            </a:r>
+            <a:r>
+              <a:rPr lang="az-Latn-AZ" altLang="en-US" sz="1300" b="1">
+                <a:latin typeface="Arial" panose="020B0604020202020204" pitchFamily="34" charset="0"/>
+              </a:rPr>
+              <a:t>route</a:t>
+            </a:r>
+            <a:r>
+              <a:rPr lang="az-Latn-AZ" altLang="en-US" sz="1300">
+                <a:latin typeface="Arial" panose="020B0604020202020204" pitchFamily="34" charset="0"/>
+              </a:rPr>
+              <a:t> -da dəyişiklik edirik.</a:t>
+            </a:r>
+          </a:p>
+          <a:p>
+            <a:pPr>
+              <a:lnSpc>
+                <a:spcPct val="150000"/>
+              </a:lnSpc>
+              <a:buNone/>
+            </a:pPr>
+            <a:endParaRPr kumimoji="0" lang="az-Latn-AZ" altLang="en-US" sz="1300" b="0" i="0" u="none" strike="noStrike" cap="none" normalizeH="0" baseline="0">
+              <a:ln>
+                <a:noFill/>
+              </a:ln>
+              <a:solidFill>
+                <a:schemeClr val="tx1"/>
+              </a:solidFill>
+              <a:effectLst/>
+              <a:latin typeface="Arial" panose="020B0604020202020204" pitchFamily="34" charset="0"/>
+            </a:endParaRPr>
+          </a:p>
+          <a:p>
+            <a:pPr>
+              <a:lnSpc>
+                <a:spcPct val="150000"/>
+              </a:lnSpc>
+              <a:buNone/>
+            </a:pPr>
+            <a:r>
+              <a:rPr lang="az-Latn-AZ" altLang="en-US" sz="1300">
+                <a:latin typeface="Arial" panose="020B0604020202020204" pitchFamily="34" charset="0"/>
+              </a:rPr>
+              <a:t>Müvəqqəti dedikdə yəni hələki controller yaratmırıq.</a:t>
+            </a:r>
+          </a:p>
+          <a:p>
+            <a:pPr>
+              <a:lnSpc>
+                <a:spcPct val="150000"/>
+              </a:lnSpc>
+              <a:buNone/>
+            </a:pPr>
+            <a:endParaRPr kumimoji="0" lang="az-Latn-AZ" altLang="en-US" sz="1300" b="0" i="0" u="none" strike="noStrike" cap="none" normalizeH="0" baseline="0">
+              <a:ln>
+                <a:noFill/>
+              </a:ln>
+              <a:solidFill>
+                <a:schemeClr val="tx1"/>
+              </a:solidFill>
+              <a:effectLst/>
+              <a:latin typeface="Arial" panose="020B0604020202020204" pitchFamily="34" charset="0"/>
+            </a:endParaRPr>
+          </a:p>
+          <a:p>
+            <a:pPr>
+              <a:lnSpc>
+                <a:spcPct val="150000"/>
+              </a:lnSpc>
+              <a:buNone/>
+            </a:pPr>
+            <a:r>
+              <a:rPr lang="en-US" altLang="en-US" sz="1300">
+                <a:latin typeface="Arial" panose="020B0604020202020204" pitchFamily="34" charset="0"/>
+              </a:rPr>
+              <a:t>5ci</a:t>
+            </a:r>
+            <a:r>
+              <a:rPr lang="az-Latn-AZ" altLang="en-US" sz="1300">
+                <a:latin typeface="Arial" panose="020B0604020202020204" pitchFamily="34" charset="0"/>
+              </a:rPr>
+              <a:t> slaydda isə, </a:t>
+            </a:r>
+            <a:r>
+              <a:rPr lang="az-Latn-AZ" altLang="en-US" sz="1300" b="1">
+                <a:latin typeface="Arial" panose="020B0604020202020204" pitchFamily="34" charset="0"/>
+              </a:rPr>
+              <a:t>master.blade.php </a:t>
+            </a:r>
+            <a:r>
+              <a:rPr lang="az-Latn-AZ" altLang="en-US" sz="1300">
+                <a:latin typeface="Arial" panose="020B0604020202020204" pitchFamily="34" charset="0"/>
+              </a:rPr>
+              <a:t>faylını</a:t>
+            </a:r>
+          </a:p>
+          <a:p>
+            <a:pPr>
+              <a:lnSpc>
+                <a:spcPct val="150000"/>
+              </a:lnSpc>
+              <a:buNone/>
+            </a:pPr>
+            <a:r>
+              <a:rPr kumimoji="0" lang="az-Latn-AZ" altLang="en-US" sz="1300" b="0" i="0" u="none" strike="noStrike" cap="none" normalizeH="0" baseline="0">
+                <a:ln>
+                  <a:noFill/>
+                </a:ln>
+                <a:solidFill>
+                  <a:schemeClr val="tx1"/>
+                </a:solidFill>
+                <a:effectLst/>
+                <a:latin typeface="Arial" panose="020B0604020202020204" pitchFamily="34" charset="0"/>
+              </a:rPr>
+              <a:t>bölgülərə ayıracağıq.</a:t>
+            </a:r>
+            <a:endParaRPr kumimoji="0" lang="en-US" altLang="en-US" sz="1300" b="0" i="0" u="none" strike="noStrike" cap="none" normalizeH="0" baseline="0">
+              <a:ln>
+                <a:noFill/>
+              </a:ln>
+              <a:solidFill>
+                <a:schemeClr val="tx1"/>
+              </a:solidFill>
+              <a:effectLst/>
+              <a:latin typeface="Arial" panose="020B0604020202020204" pitchFamily="34" charset="0"/>
+            </a:endParaRPr>
+          </a:p>
+        </p:txBody>
+      </p:sp>
+      <p:pic>
+        <p:nvPicPr>
+          <p:cNvPr id="6" name="Picture 5">
+            <a:extLst>
+              <a:ext uri="{FF2B5EF4-FFF2-40B4-BE49-F238E27FC236}">
+                <a16:creationId xmlns:a16="http://schemas.microsoft.com/office/drawing/2014/main" id="{2B519754-203E-0503-E40B-E0E223A810B2}"/>
+              </a:ext>
+            </a:extLst>
+          </p:cNvPr>
+          <p:cNvPicPr>
+            <a:picLocks noChangeAspect="1"/>
+          </p:cNvPicPr>
+          <p:nvPr/>
+        </p:nvPicPr>
+        <p:blipFill>
+          <a:blip r:embed="rId2"/>
+          <a:stretch>
+            <a:fillRect/>
+          </a:stretch>
+        </p:blipFill>
+        <p:spPr>
+          <a:xfrm>
+            <a:off x="5066306" y="1666150"/>
+            <a:ext cx="7125694" cy="5191850"/>
+          </a:xfrm>
+          <a:prstGeom prst="rect">
+            <a:avLst/>
+          </a:prstGeom>
+        </p:spPr>
+      </p:pic>
+    </p:spTree>
+    <p:extLst>
+      <p:ext uri="{BB962C8B-B14F-4D97-AF65-F5344CB8AC3E}">
+        <p14:creationId xmlns:p14="http://schemas.microsoft.com/office/powerpoint/2010/main" val="3993536694"/>
+      </p:ext>
+    </p:extLst>
+  </p:cSld>
+  <p:clrMapOvr>
+    <a:masterClrMapping/>
+  </p:clrMapOvr>
+</p:sld>
+</file>
+
+<file path=ppt/slides/slide4.xml><?xml version="1.0" encoding="utf-8"?>
+<p:sld xmlns:a="http://schemas.openxmlformats.org/drawingml/2006/main" xmlns:r="http://schemas.openxmlformats.org/officeDocument/2006/relationships" xmlns:p="http://schemas.openxmlformats.org/presentationml/2006/main">
+  <p:cSld>
+    <p:spTree>
+      <p:nvGrpSpPr>
+        <p:cNvPr id="1" name="">
+          <a:extLst>
+            <a:ext uri="{FF2B5EF4-FFF2-40B4-BE49-F238E27FC236}">
+              <a16:creationId xmlns:a16="http://schemas.microsoft.com/office/drawing/2014/main" id="{8A25D35E-6461-01CA-D0C5-EF387D88844E}"/>
+            </a:ext>
+          </a:extLst>
+        </p:cNvPr>
+        <p:cNvGrpSpPr/>
+        <p:nvPr/>
+      </p:nvGrpSpPr>
+      <p:grpSpPr>
+        <a:xfrm>
+          <a:off x="0" y="0"/>
+          <a:ext cx="0" cy="0"/>
+          <a:chOff x="0" y="0"/>
+          <a:chExt cx="0" cy="0"/>
+        </a:xfrm>
+      </p:grpSpPr>
+      <p:sp>
+        <p:nvSpPr>
+          <p:cNvPr id="3" name="TextBox 2">
+            <a:extLst>
+              <a:ext uri="{FF2B5EF4-FFF2-40B4-BE49-F238E27FC236}">
+                <a16:creationId xmlns:a16="http://schemas.microsoft.com/office/drawing/2014/main" id="{45EAFE89-89CB-AC3D-5C98-984ECC2B189F}"/>
+              </a:ext>
+            </a:extLst>
+          </p:cNvPr>
+          <p:cNvSpPr txBox="1"/>
+          <p:nvPr/>
+        </p:nvSpPr>
+        <p:spPr>
+          <a:xfrm>
+            <a:off x="217714" y="133748"/>
+            <a:ext cx="11756571" cy="355354"/>
+          </a:xfrm>
+          <a:prstGeom prst="rect">
+            <a:avLst/>
+          </a:prstGeom>
+          <a:noFill/>
+        </p:spPr>
+        <p:txBody>
+          <a:bodyPr wrap="square">
+            <a:spAutoFit/>
+          </a:bodyPr>
+          <a:lstStyle/>
+          <a:p>
+            <a:pPr>
+              <a:lnSpc>
+                <a:spcPct val="150000"/>
+              </a:lnSpc>
+              <a:buNone/>
+            </a:pPr>
+            <a:r>
+              <a:rPr lang="en-US" altLang="en-US" sz="1300">
+                <a:latin typeface="Arial" panose="020B0604020202020204" pitchFamily="34" charset="0"/>
+              </a:rPr>
+              <a:t>N</a:t>
+            </a:r>
+            <a:r>
+              <a:rPr lang="az-Latn-AZ" altLang="en-US" sz="1300">
+                <a:latin typeface="Arial" panose="020B0604020202020204" pitchFamily="34" charset="0"/>
+              </a:rPr>
+              <a:t>əticə...</a:t>
+            </a:r>
+            <a:endParaRPr kumimoji="0" lang="en-US" altLang="en-US" sz="1300" b="0" i="0" u="none" strike="noStrike" cap="none" normalizeH="0" baseline="0">
+              <a:ln>
+                <a:noFill/>
+              </a:ln>
+              <a:solidFill>
+                <a:schemeClr val="tx1"/>
+              </a:solidFill>
+              <a:effectLst/>
+              <a:latin typeface="Arial" panose="020B0604020202020204" pitchFamily="34" charset="0"/>
+            </a:endParaRPr>
+          </a:p>
+        </p:txBody>
+      </p:sp>
+      <p:pic>
+        <p:nvPicPr>
+          <p:cNvPr id="4" name="Picture 3">
+            <a:extLst>
+              <a:ext uri="{FF2B5EF4-FFF2-40B4-BE49-F238E27FC236}">
+                <a16:creationId xmlns:a16="http://schemas.microsoft.com/office/drawing/2014/main" id="{11C936E7-56B7-1C2A-3DCA-126DE83D5FB1}"/>
+              </a:ext>
+            </a:extLst>
+          </p:cNvPr>
+          <p:cNvPicPr>
+            <a:picLocks noChangeAspect="1"/>
+          </p:cNvPicPr>
+          <p:nvPr/>
+        </p:nvPicPr>
+        <p:blipFill>
+          <a:blip r:embed="rId2"/>
+          <a:stretch>
+            <a:fillRect/>
+          </a:stretch>
+        </p:blipFill>
+        <p:spPr>
+          <a:xfrm>
+            <a:off x="0" y="574577"/>
+            <a:ext cx="12192000" cy="6283423"/>
+          </a:xfrm>
+          <a:prstGeom prst="rect">
+            <a:avLst/>
+          </a:prstGeom>
+        </p:spPr>
+      </p:pic>
+    </p:spTree>
+    <p:extLst>
+      <p:ext uri="{BB962C8B-B14F-4D97-AF65-F5344CB8AC3E}">
+        <p14:creationId xmlns:p14="http://schemas.microsoft.com/office/powerpoint/2010/main" val="2739406203"/>
+      </p:ext>
+    </p:extLst>
+  </p:cSld>
+  <p:clrMapOvr>
+    <a:masterClrMapping/>
+  </p:clrMapOvr>
+</p:sld>
+</file>
+
+<file path=ppt/slides/slide5.xml><?xml version="1.0" encoding="utf-8"?>
+<p:sld xmlns:a="http://schemas.openxmlformats.org/drawingml/2006/main" xmlns:r="http://schemas.openxmlformats.org/officeDocument/2006/relationships" xmlns:p="http://schemas.openxmlformats.org/presentationml/2006/main">
+  <p:cSld>
+    <p:spTree>
+      <p:nvGrpSpPr>
+        <p:cNvPr id="1" name="">
+          <a:extLst>
+            <a:ext uri="{FF2B5EF4-FFF2-40B4-BE49-F238E27FC236}">
+              <a16:creationId xmlns:a16="http://schemas.microsoft.com/office/drawing/2014/main" id="{E02ED3CB-0572-8B3F-BA2A-66FC0E25E5BD}"/>
+            </a:ext>
+          </a:extLst>
+        </p:cNvPr>
+        <p:cNvGrpSpPr/>
+        <p:nvPr/>
+      </p:nvGrpSpPr>
+      <p:grpSpPr>
+        <a:xfrm>
+          <a:off x="0" y="0"/>
+          <a:ext cx="0" cy="0"/>
+          <a:chOff x="0" y="0"/>
+          <a:chExt cx="0" cy="0"/>
+        </a:xfrm>
+      </p:grpSpPr>
+      <p:sp>
+        <p:nvSpPr>
+          <p:cNvPr id="3" name="TextBox 2">
+            <a:extLst>
+              <a:ext uri="{FF2B5EF4-FFF2-40B4-BE49-F238E27FC236}">
+                <a16:creationId xmlns:a16="http://schemas.microsoft.com/office/drawing/2014/main" id="{B8CCB4E1-6ACB-1AD0-5AB5-3025BEE88123}"/>
+              </a:ext>
+            </a:extLst>
+          </p:cNvPr>
+          <p:cNvSpPr txBox="1"/>
+          <p:nvPr/>
+        </p:nvSpPr>
+        <p:spPr>
+          <a:xfrm>
+            <a:off x="217714" y="255046"/>
+            <a:ext cx="11756571" cy="955518"/>
+          </a:xfrm>
+          <a:prstGeom prst="rect">
+            <a:avLst/>
+          </a:prstGeom>
+          <a:noFill/>
+        </p:spPr>
+        <p:txBody>
+          <a:bodyPr wrap="square">
+            <a:spAutoFit/>
+          </a:bodyPr>
+          <a:lstStyle/>
+          <a:p>
+            <a:pPr marL="342900" indent="-342900">
+              <a:lnSpc>
+                <a:spcPct val="150000"/>
+              </a:lnSpc>
+              <a:buFont typeface="+mj-lt"/>
+              <a:buAutoNum type="arabicPeriod"/>
+            </a:pPr>
+            <a:r>
+              <a:rPr lang="az-Latn-AZ" altLang="en-US" sz="1300" b="1">
+                <a:latin typeface="Arial" panose="020B0604020202020204" pitchFamily="34" charset="0"/>
+              </a:rPr>
+              <a:t>master.blade.php </a:t>
+            </a:r>
+            <a:r>
+              <a:rPr lang="az-Latn-AZ" altLang="en-US" sz="1300">
+                <a:latin typeface="Arial" panose="020B0604020202020204" pitchFamily="34" charset="0"/>
+              </a:rPr>
+              <a:t>faylını bölgülərə ayırmaq üçün, `</a:t>
+            </a:r>
+            <a:r>
+              <a:rPr lang="en-US" altLang="en-US" sz="1300" b="1">
+                <a:latin typeface="Arial" panose="020B0604020202020204" pitchFamily="34" charset="0"/>
+              </a:rPr>
+              <a:t>resources\views\frontend\dashboard\</a:t>
+            </a:r>
+            <a:r>
+              <a:rPr lang="en-US" altLang="en-US" sz="1300" b="1" u="sng">
+                <a:latin typeface="Arial" panose="020B0604020202020204" pitchFamily="34" charset="0"/>
+              </a:rPr>
+              <a:t>dashboard.blade.php</a:t>
+            </a:r>
+            <a:r>
+              <a:rPr lang="az-Latn-AZ" altLang="en-US" sz="1300">
+                <a:latin typeface="Arial" panose="020B0604020202020204" pitchFamily="34" charset="0"/>
+              </a:rPr>
+              <a:t>` adında fayl yaradırıq və sabit hissələri </a:t>
+            </a:r>
+            <a:r>
+              <a:rPr lang="az-Latn-AZ" altLang="en-US" sz="1300" b="1">
+                <a:solidFill>
+                  <a:srgbClr val="00B050"/>
+                </a:solidFill>
+                <a:latin typeface="Arial" panose="020B0604020202020204" pitchFamily="34" charset="0"/>
+              </a:rPr>
+              <a:t>master</a:t>
+            </a:r>
+            <a:r>
+              <a:rPr lang="az-Latn-AZ" altLang="en-US" sz="1300">
+                <a:latin typeface="Arial" panose="020B0604020202020204" pitchFamily="34" charset="0"/>
+              </a:rPr>
+              <a:t> faylında dəyişəcək hissələri isə </a:t>
+            </a:r>
+            <a:r>
+              <a:rPr lang="az-Latn-AZ" altLang="en-US" sz="1300" b="1">
+                <a:solidFill>
+                  <a:srgbClr val="0070C0"/>
+                </a:solidFill>
+                <a:latin typeface="Arial" panose="020B0604020202020204" pitchFamily="34" charset="0"/>
+              </a:rPr>
+              <a:t>dashboard</a:t>
+            </a:r>
+            <a:r>
+              <a:rPr lang="az-Latn-AZ" altLang="en-US" sz="1300">
+                <a:latin typeface="Arial" panose="020B0604020202020204" pitchFamily="34" charset="0"/>
+              </a:rPr>
+              <a:t> faylında saxlayırıq.</a:t>
+            </a:r>
+            <a:endParaRPr lang="en-US" altLang="en-US" sz="1300">
+              <a:latin typeface="Arial" panose="020B0604020202020204" pitchFamily="34" charset="0"/>
+            </a:endParaRPr>
+          </a:p>
+          <a:p>
+            <a:pPr marL="342900" indent="-342900">
+              <a:lnSpc>
+                <a:spcPct val="150000"/>
+              </a:lnSpc>
+              <a:buFont typeface="+mj-lt"/>
+              <a:buAutoNum type="arabicPeriod"/>
+            </a:pPr>
+            <a:r>
+              <a:rPr lang="en-US" altLang="en-US" sz="1300" b="1">
+                <a:latin typeface="Arial" panose="020B0604020202020204" pitchFamily="34" charset="0"/>
+              </a:rPr>
+              <a:t>routes\web.php </a:t>
+            </a:r>
+            <a:r>
+              <a:rPr lang="en-US" altLang="en-US" sz="1300">
+                <a:latin typeface="Arial" panose="020B0604020202020204" pitchFamily="34" charset="0"/>
+              </a:rPr>
+              <a:t>fayl</a:t>
+            </a:r>
+            <a:r>
+              <a:rPr lang="az-Latn-AZ" altLang="en-US" sz="1300">
+                <a:latin typeface="Arial" panose="020B0604020202020204" pitchFamily="34" charset="0"/>
+              </a:rPr>
+              <a:t>ında isə </a:t>
+            </a:r>
+            <a:r>
+              <a:rPr lang="az-Latn-AZ" altLang="en-US" sz="1300" b="1">
+                <a:latin typeface="Arial" panose="020B0604020202020204" pitchFamily="34" charset="0"/>
+              </a:rPr>
+              <a:t>route</a:t>
+            </a:r>
+            <a:r>
+              <a:rPr lang="az-Latn-AZ" altLang="en-US" sz="1300">
+                <a:latin typeface="Arial" panose="020B0604020202020204" pitchFamily="34" charset="0"/>
+              </a:rPr>
+              <a:t> -un yolunu </a:t>
+            </a:r>
+            <a:r>
+              <a:rPr lang="az-Latn-AZ" altLang="en-US" sz="1300" b="1">
+                <a:latin typeface="Arial" panose="020B0604020202020204" pitchFamily="34" charset="0"/>
+              </a:rPr>
+              <a:t>dashboard</a:t>
+            </a:r>
+            <a:r>
+              <a:rPr lang="az-Latn-AZ" altLang="en-US" sz="1300">
+                <a:latin typeface="Arial" panose="020B0604020202020204" pitchFamily="34" charset="0"/>
+              </a:rPr>
+              <a:t> olaraq dəyişdiririk, əks halda sadəcə səhifənin bir hissəsi görünər.</a:t>
+            </a:r>
+            <a:endParaRPr lang="en-US" altLang="en-US" sz="1300">
+              <a:latin typeface="Arial" panose="020B0604020202020204" pitchFamily="34" charset="0"/>
+            </a:endParaRPr>
+          </a:p>
+        </p:txBody>
+      </p:sp>
+      <p:pic>
+        <p:nvPicPr>
+          <p:cNvPr id="4" name="Picture 3">
+            <a:extLst>
+              <a:ext uri="{FF2B5EF4-FFF2-40B4-BE49-F238E27FC236}">
+                <a16:creationId xmlns:a16="http://schemas.microsoft.com/office/drawing/2014/main" id="{728C31EA-A194-0E62-15A5-82A7B32D7F56}"/>
+              </a:ext>
+            </a:extLst>
+          </p:cNvPr>
+          <p:cNvPicPr>
+            <a:picLocks noChangeAspect="1"/>
+          </p:cNvPicPr>
+          <p:nvPr/>
+        </p:nvPicPr>
+        <p:blipFill>
+          <a:blip r:embed="rId2"/>
+          <a:stretch>
+            <a:fillRect/>
+          </a:stretch>
+        </p:blipFill>
+        <p:spPr>
+          <a:xfrm>
+            <a:off x="-1" y="1464567"/>
+            <a:ext cx="10077062" cy="5393433"/>
+          </a:xfrm>
+          <a:prstGeom prst="rect">
+            <a:avLst/>
+          </a:prstGeom>
+        </p:spPr>
+      </p:pic>
+    </p:spTree>
+    <p:extLst>
+      <p:ext uri="{BB962C8B-B14F-4D97-AF65-F5344CB8AC3E}">
+        <p14:creationId xmlns:p14="http://schemas.microsoft.com/office/powerpoint/2010/main" val="3418579384"/>
+      </p:ext>
+    </p:extLst>
+  </p:cSld>
+  <p:clrMapOvr>
+    <a:masterClrMapping/>
+  </p:clrMapOvr>
+</p:sld>
+</file>
+
+<file path=ppt/slides/slide6.xml><?xml version="1.0" encoding="utf-8"?>
+<p:sld xmlns:a="http://schemas.openxmlformats.org/drawingml/2006/main" xmlns:r="http://schemas.openxmlformats.org/officeDocument/2006/relationships" xmlns:p="http://schemas.openxmlformats.org/presentationml/2006/main">
+  <p:cSld>
+    <p:spTree>
+      <p:nvGrpSpPr>
+        <p:cNvPr id="1" name="">
+          <a:extLst>
+            <a:ext uri="{FF2B5EF4-FFF2-40B4-BE49-F238E27FC236}">
+              <a16:creationId xmlns:a16="http://schemas.microsoft.com/office/drawing/2014/main" id="{E5D55FD9-4E3E-72FD-BA0F-010AA6013021}"/>
+            </a:ext>
+          </a:extLst>
+        </p:cNvPr>
+        <p:cNvGrpSpPr/>
+        <p:nvPr/>
+      </p:nvGrpSpPr>
+      <p:grpSpPr>
+        <a:xfrm>
+          <a:off x="0" y="0"/>
+          <a:ext cx="0" cy="0"/>
+          <a:chOff x="0" y="0"/>
+          <a:chExt cx="0" cy="0"/>
+        </a:xfrm>
+      </p:grpSpPr>
+      <p:sp>
+        <p:nvSpPr>
+          <p:cNvPr id="3" name="TextBox 2">
+            <a:extLst>
+              <a:ext uri="{FF2B5EF4-FFF2-40B4-BE49-F238E27FC236}">
+                <a16:creationId xmlns:a16="http://schemas.microsoft.com/office/drawing/2014/main" id="{D2CB64B2-2E33-03E1-6EA7-85A59679EE47}"/>
+              </a:ext>
+            </a:extLst>
+          </p:cNvPr>
+          <p:cNvSpPr txBox="1"/>
+          <p:nvPr/>
+        </p:nvSpPr>
+        <p:spPr>
+          <a:xfrm>
+            <a:off x="217714" y="255046"/>
+            <a:ext cx="11756571" cy="955518"/>
+          </a:xfrm>
+          <a:prstGeom prst="rect">
+            <a:avLst/>
+          </a:prstGeom>
+          <a:noFill/>
+        </p:spPr>
+        <p:txBody>
+          <a:bodyPr wrap="square">
+            <a:spAutoFit/>
+          </a:bodyPr>
+          <a:lstStyle/>
+          <a:p>
+            <a:pPr>
+              <a:lnSpc>
+                <a:spcPct val="150000"/>
+              </a:lnSpc>
+              <a:buNone/>
+            </a:pPr>
+            <a:r>
+              <a:rPr lang="en-US" altLang="en-US" sz="1300">
+                <a:latin typeface="Arial" panose="020B0604020202020204" pitchFamily="34" charset="0"/>
+              </a:rPr>
+              <a:t>`</a:t>
+            </a:r>
+            <a:r>
+              <a:rPr lang="en-US" altLang="en-US" sz="1300" b="1">
+                <a:latin typeface="Arial" panose="020B0604020202020204" pitchFamily="34" charset="0"/>
+              </a:rPr>
+              <a:t>resources\views\frontend\dashboard\</a:t>
+            </a:r>
+            <a:r>
+              <a:rPr lang="en-US" altLang="en-US" sz="1300" b="1" u="sng">
+                <a:latin typeface="Arial" panose="020B0604020202020204" pitchFamily="34" charset="0"/>
+              </a:rPr>
+              <a:t>dashboard.blade.php</a:t>
+            </a:r>
+            <a:r>
+              <a:rPr lang="en-US" altLang="en-US" sz="1300">
+                <a:latin typeface="Arial" panose="020B0604020202020204" pitchFamily="34" charset="0"/>
+              </a:rPr>
+              <a:t>` fayl</a:t>
+            </a:r>
+            <a:r>
+              <a:rPr lang="az-Latn-AZ" altLang="en-US" sz="1300">
+                <a:latin typeface="Arial" panose="020B0604020202020204" pitchFamily="34" charset="0"/>
+              </a:rPr>
+              <a:t>ında, təkrarlanmayan hissə olan </a:t>
+            </a:r>
+            <a:r>
+              <a:rPr lang="az-Latn-AZ" altLang="en-US" sz="1300" b="1">
+                <a:latin typeface="Arial" panose="020B0604020202020204" pitchFamily="34" charset="0"/>
+              </a:rPr>
+              <a:t>Sidebar</a:t>
+            </a:r>
+            <a:r>
+              <a:rPr lang="az-Latn-AZ" altLang="en-US" sz="1300">
+                <a:latin typeface="Arial" panose="020B0604020202020204" pitchFamily="34" charset="0"/>
+              </a:rPr>
+              <a:t> -a məxsus elementlər üçündə,  `</a:t>
+            </a:r>
+            <a:r>
+              <a:rPr lang="en-US" altLang="en-US" sz="1300" b="1">
+                <a:latin typeface="Arial" panose="020B0604020202020204" pitchFamily="34" charset="0"/>
+              </a:rPr>
+              <a:t>resources\views\frontend\dashboard\layouts\</a:t>
+            </a:r>
+            <a:r>
+              <a:rPr lang="en-US" altLang="en-US" sz="1300" b="1" u="sng">
+                <a:latin typeface="Arial" panose="020B0604020202020204" pitchFamily="34" charset="0"/>
+              </a:rPr>
+              <a:t>sidebar.blade.php</a:t>
+            </a:r>
+            <a:r>
+              <a:rPr lang="az-Latn-AZ" altLang="en-US" sz="1300">
+                <a:latin typeface="Arial" panose="020B0604020202020204" pitchFamily="34" charset="0"/>
+              </a:rPr>
+              <a:t>` adında fayl yaradaraq, həmin elementləri bu fayla köçürürük və </a:t>
+            </a:r>
+            <a:r>
+              <a:rPr lang="en-US" altLang="en-US" sz="1300" b="1">
+                <a:latin typeface="Arial" panose="020B0604020202020204" pitchFamily="34" charset="0"/>
+              </a:rPr>
+              <a:t>@include </a:t>
+            </a:r>
+            <a:r>
+              <a:rPr lang="az-Latn-AZ" altLang="en-US" sz="1300">
+                <a:latin typeface="Arial" panose="020B0604020202020204" pitchFamily="34" charset="0"/>
+              </a:rPr>
+              <a:t>direktivi ilə çağırırıq.</a:t>
+            </a:r>
+            <a:endParaRPr kumimoji="0" lang="en-US" altLang="en-US" sz="1300" b="0" i="0" u="none" strike="noStrike" cap="none" normalizeH="0" baseline="0">
+              <a:ln>
+                <a:noFill/>
+              </a:ln>
+              <a:solidFill>
+                <a:schemeClr val="tx1"/>
+              </a:solidFill>
+              <a:effectLst/>
+              <a:latin typeface="Arial" panose="020B0604020202020204" pitchFamily="34" charset="0"/>
+            </a:endParaRPr>
+          </a:p>
+        </p:txBody>
+      </p:sp>
+      <p:pic>
+        <p:nvPicPr>
+          <p:cNvPr id="4" name="Picture 3">
+            <a:extLst>
+              <a:ext uri="{FF2B5EF4-FFF2-40B4-BE49-F238E27FC236}">
+                <a16:creationId xmlns:a16="http://schemas.microsoft.com/office/drawing/2014/main" id="{EA51B2DD-0B86-B20A-3A9D-B497D73E09F7}"/>
+              </a:ext>
+            </a:extLst>
+          </p:cNvPr>
+          <p:cNvPicPr>
+            <a:picLocks noChangeAspect="1"/>
+          </p:cNvPicPr>
+          <p:nvPr/>
+        </p:nvPicPr>
+        <p:blipFill>
+          <a:blip r:embed="rId2"/>
+          <a:srcRect b="27332"/>
+          <a:stretch>
+            <a:fillRect/>
+          </a:stretch>
+        </p:blipFill>
+        <p:spPr>
+          <a:xfrm>
+            <a:off x="0" y="2343065"/>
+            <a:ext cx="12192000" cy="4514935"/>
+          </a:xfrm>
+          <a:prstGeom prst="rect">
+            <a:avLst/>
+          </a:prstGeom>
+        </p:spPr>
+      </p:pic>
+    </p:spTree>
+    <p:extLst>
+      <p:ext uri="{BB962C8B-B14F-4D97-AF65-F5344CB8AC3E}">
+        <p14:creationId xmlns:p14="http://schemas.microsoft.com/office/powerpoint/2010/main" val="3123306937"/>
+      </p:ext>
+    </p:extLst>
+  </p:cSld>
+  <p:clrMapOvr>
+    <a:masterClrMapping/>
+  </p:clrMapOvr>
+</p:sld>
+</file>
+
+<file path=ppt/slides/slide7.xml><?xml version="1.0" encoding="utf-8"?>
+<p:sld xmlns:a="http://schemas.openxmlformats.org/drawingml/2006/main" xmlns:r="http://schemas.openxmlformats.org/officeDocument/2006/relationships" xmlns:p="http://schemas.openxmlformats.org/presentationml/2006/main">
+  <p:cSld>
+    <p:spTree>
+      <p:nvGrpSpPr>
+        <p:cNvPr id="1" name="">
+          <a:extLst>
+            <a:ext uri="{FF2B5EF4-FFF2-40B4-BE49-F238E27FC236}">
+              <a16:creationId xmlns:a16="http://schemas.microsoft.com/office/drawing/2014/main" id="{6E881DFB-F258-4B43-90F6-D8B2FA7DF5CF}"/>
+            </a:ext>
+          </a:extLst>
+        </p:cNvPr>
+        <p:cNvGrpSpPr/>
+        <p:nvPr/>
+      </p:nvGrpSpPr>
+      <p:grpSpPr>
+        <a:xfrm>
+          <a:off x="0" y="0"/>
+          <a:ext cx="0" cy="0"/>
+          <a:chOff x="0" y="0"/>
+          <a:chExt cx="0" cy="0"/>
+        </a:xfrm>
+      </p:grpSpPr>
+      <p:sp>
+        <p:nvSpPr>
+          <p:cNvPr id="3" name="TextBox 2">
+            <a:extLst>
+              <a:ext uri="{FF2B5EF4-FFF2-40B4-BE49-F238E27FC236}">
+                <a16:creationId xmlns:a16="http://schemas.microsoft.com/office/drawing/2014/main" id="{AF2EFA25-0BBE-7B2F-44E4-1A70E5D3817B}"/>
+              </a:ext>
+            </a:extLst>
+          </p:cNvPr>
+          <p:cNvSpPr txBox="1"/>
+          <p:nvPr/>
+        </p:nvSpPr>
+        <p:spPr>
+          <a:xfrm>
+            <a:off x="217714" y="255046"/>
+            <a:ext cx="11756571" cy="355354"/>
+          </a:xfrm>
+          <a:prstGeom prst="rect">
+            <a:avLst/>
+          </a:prstGeom>
+          <a:noFill/>
+        </p:spPr>
+        <p:txBody>
+          <a:bodyPr wrap="square">
+            <a:spAutoFit/>
+          </a:bodyPr>
+          <a:lstStyle/>
+          <a:p>
+            <a:pPr>
+              <a:lnSpc>
+                <a:spcPct val="150000"/>
+              </a:lnSpc>
+              <a:buNone/>
+            </a:pPr>
+            <a:r>
+              <a:rPr kumimoji="0" lang="en-US" altLang="en-US" sz="1300" b="0" i="0" u="none" strike="noStrike" cap="none" normalizeH="0" baseline="0">
+                <a:ln>
+                  <a:noFill/>
+                </a:ln>
+                <a:solidFill>
+                  <a:schemeClr val="tx1"/>
+                </a:solidFill>
+                <a:effectLst/>
+                <a:latin typeface="Arial" panose="020B0604020202020204" pitchFamily="34" charset="0"/>
+              </a:rPr>
+              <a:t>.</a:t>
+            </a:r>
+          </a:p>
+        </p:txBody>
+      </p:sp>
+    </p:spTree>
+    <p:extLst>
+      <p:ext uri="{BB962C8B-B14F-4D97-AF65-F5344CB8AC3E}">
+        <p14:creationId xmlns:p14="http://schemas.microsoft.com/office/powerpoint/2010/main" val="3099675274"/>
+      </p:ext>
+    </p:extLst>
+  </p:cSld>
+  <p:clrMapOvr>
+    <a:masterClrMapping/>
+  </p:clrMapOvr>
+</p:sld>
+</file>
+
+<file path=ppt/slides/slide8.xml><?xml version="1.0" encoding="utf-8"?>
 <p:sld xmlns:a="http://schemas.openxmlformats.org/drawingml/2006/main" xmlns:r="http://schemas.openxmlformats.org/officeDocument/2006/relationships" xmlns:p="http://schemas.openxmlformats.org/presentationml/2006/main">
   <p:cSld>
     <p:spTree>

</xml_diff>